<commit_message>
fix: audit and correct 23 investor data errors across all 120 decks - Fix Shield Capital: Raj Shah was DIU head, NOT NSA Director - Fix Nyca Partners: founded by Hans Morris, OCC Comptroller is advisor - Fix Craft Ventures: remove SpaceX/Palantir (not Craft investments) - Fix 20 portfolio misattributions across files - Regenerate all 120 HTML, PDF, PPTX decks with corrected data
</commit_message>
<xml_diff>
--- a/docs/pitch-decks/investor-100/pptx/010-felicis.pptx
+++ b/docs/pitch-decks/investor-100/pptx/010-felicis.pptx
@@ -3001,7 +3001,7 @@
                   <a:srgbClr val="D4AF37"/>
                 </a:solidFill>
               </a:rPr>
-              <a:t>Plaid</a:t>
+              <a:t>Credit Karma</a:t>
             </a:r>
             <a:endParaRPr lang="en-US" sz="1100" dirty="0"/>
           </a:p>
@@ -3019,7 +3019,7 @@
                   <a:srgbClr val="D4AF37"/>
                 </a:solidFill>
               </a:rPr>
-              <a:t>Notion</a:t>
+              <a:t>Fitbit</a:t>
             </a:r>
             <a:endParaRPr lang="en-US" sz="1100" dirty="0"/>
           </a:p>
@@ -3076,7 +3076,7 @@
                   <a:srgbClr val="8B8FA3"/>
                 </a:solidFill>
               </a:rPr>
-              <a:t>Felicis backs globally-scaling platforms (Adyen, Shopify, Plaid). Datacendia covers 23 jurisdictions with sovereign deployment — built for global enterprise from inception.</a:t>
+              <a:t>Felicis backs globally-scaling platforms (Adyen, Shopify, Credit Karma). Datacendia covers 23 jurisdictions with sovereign deployment — built for global enterprise from inception.</a:t>
             </a:r>
             <a:endParaRPr lang="en-US" sz="1100" dirty="0"/>
           </a:p>

</xml_diff>